<commit_message>
Expand lesson two calendar and HTML tool course
</commit_message>
<xml_diff>
--- a/class/ppt/lesson-02.pptx
+++ b/class/ppt/lesson-02.pptx
@@ -2,20 +2,20 @@
 <file path=ppt/presentation.xml><?xml version="1.0" encoding="utf-8"?>
 <p:presentation xmlns:p="http://schemas.openxmlformats.org/presentationml/2006/main">
   <p:sldMasterIdLst>
-    <p:sldMasterId xmlns:r="http://schemas.openxmlformats.org/officeDocument/2006/relationships" id="2147483648" r:id="Rbbd50510f65a4b26"/>
+    <p:sldMasterId xmlns:r="http://schemas.openxmlformats.org/officeDocument/2006/relationships" id="2147483648" r:id="R4623a546b5954942"/>
   </p:sldMasterIdLst>
   <p:notesMasterIdLst>
-    <p:notesMasterId xmlns:r="http://schemas.openxmlformats.org/officeDocument/2006/relationships" r:id="Rf2a20a94725d42c1"/>
+    <p:notesMasterId xmlns:r="http://schemas.openxmlformats.org/officeDocument/2006/relationships" r:id="R46e810e017db4ed1"/>
   </p:notesMasterIdLst>
   <p:sldIdLst>
-    <p:sldId xmlns:r="http://schemas.openxmlformats.org/officeDocument/2006/relationships" id="256" r:id="R27eb957eb1a64d7d"/>
-    <p:sldId xmlns:r="http://schemas.openxmlformats.org/officeDocument/2006/relationships" id="257" r:id="Rbae6811cb2174986"/>
-    <p:sldId xmlns:r="http://schemas.openxmlformats.org/officeDocument/2006/relationships" id="258" r:id="R0bb74cb9c0a74280"/>
-    <p:sldId xmlns:r="http://schemas.openxmlformats.org/officeDocument/2006/relationships" id="259" r:id="R034e1acfb6e04ef4"/>
-    <p:sldId xmlns:r="http://schemas.openxmlformats.org/officeDocument/2006/relationships" id="260" r:id="Rdb149f5603c94c01"/>
-    <p:sldId xmlns:r="http://schemas.openxmlformats.org/officeDocument/2006/relationships" id="261" r:id="R359c1a63e06a4285"/>
-    <p:sldId xmlns:r="http://schemas.openxmlformats.org/officeDocument/2006/relationships" id="262" r:id="R232b8516640349d9"/>
-    <p:sldId xmlns:r="http://schemas.openxmlformats.org/officeDocument/2006/relationships" id="263" r:id="R69201025227c4117"/>
+    <p:sldId xmlns:r="http://schemas.openxmlformats.org/officeDocument/2006/relationships" id="256" r:id="Ra6cc5915c6564d50"/>
+    <p:sldId xmlns:r="http://schemas.openxmlformats.org/officeDocument/2006/relationships" id="257" r:id="R0f45883948204ff3"/>
+    <p:sldId xmlns:r="http://schemas.openxmlformats.org/officeDocument/2006/relationships" id="258" r:id="R4950970a3c1c4553"/>
+    <p:sldId xmlns:r="http://schemas.openxmlformats.org/officeDocument/2006/relationships" id="259" r:id="R2e0dc6be51164c9d"/>
+    <p:sldId xmlns:r="http://schemas.openxmlformats.org/officeDocument/2006/relationships" id="260" r:id="R540149ff2e4842c1"/>
+    <p:sldId xmlns:r="http://schemas.openxmlformats.org/officeDocument/2006/relationships" id="261" r:id="Rbf746f1f07424423"/>
+    <p:sldId xmlns:r="http://schemas.openxmlformats.org/officeDocument/2006/relationships" id="262" r:id="R605f4157eee84fe3"/>
+    <p:sldId xmlns:r="http://schemas.openxmlformats.org/officeDocument/2006/relationships" id="263" r:id="Rb21d32add92344f8"/>
   </p:sldIdLst>
   <p:sldSz cx="12192000" cy="6858000"/>
   <p:notesSz cx="6858000" cy="9144000"/>
@@ -1127,7 +1127,7 @@
   </p:cSld>
   <p:clrMap bg1="lt1" tx1="dk1" bg2="lt2" tx2="dk2" accent1="accent1" accent2="accent2" accent3="accent3" accent4="accent4" accent5="accent5" accent6="accent6" hlink="hlink" folHlink="folHlink"/>
   <p:sldLayoutIdLst>
-    <p:sldLayoutId xmlns:r="http://schemas.openxmlformats.org/officeDocument/2006/relationships" id="2147483649" r:id="R244fb615cc384d5d"/>
+    <p:sldLayoutId xmlns:r="http://schemas.openxmlformats.org/officeDocument/2006/relationships" id="2147483649" r:id="R0c990d311d9e4cc1"/>
   </p:sldLayoutIdLst>
   <p:txStyles>
     <p:titleStyle>
@@ -1678,7 +1678,7 @@
           <p:cNvPr id="8" name="">
             <a:extLst xmlns:a="http://schemas.openxmlformats.org/drawingml/2006/main">
               <a:ext uri="{FF2B5EF4-FFF2-40B4-BE49-F238E27FC236}">
-                <a16:creationId xmlns:a16="http://schemas.microsoft.com/office/drawing/2014/main" id="{40AF1939-325A-429E-809B-84851B221E9C}"/>
+                <a16:creationId xmlns:a16="http://schemas.microsoft.com/office/drawing/2014/main" id="{CCF416C5-3175-41C3-8B9C-ACDDB4003A3C}"/>
               </a:ext>
             </a:extLst>
           </p:cNvPr>
@@ -1711,7 +1711,7 @@
           <p:cNvPr id="2" name="">
             <a:extLst xmlns:a="http://schemas.openxmlformats.org/drawingml/2006/main">
               <a:ext uri="{FF2B5EF4-FFF2-40B4-BE49-F238E27FC236}">
-                <a16:creationId xmlns:a16="http://schemas.microsoft.com/office/drawing/2014/main" id="{0EE56654-19F8-448A-8974-504855C88BDE}"/>
+                <a16:creationId xmlns:a16="http://schemas.microsoft.com/office/drawing/2014/main" id="{55A43E84-0139-4824-90FF-3BE19016D2FD}"/>
               </a:ext>
             </a:extLst>
           </p:cNvPr>
@@ -1761,7 +1761,7 @@
           <p:cNvPr id="3" name="">
             <a:extLst xmlns:a="http://schemas.openxmlformats.org/drawingml/2006/main">
               <a:ext uri="{FF2B5EF4-FFF2-40B4-BE49-F238E27FC236}">
-                <a16:creationId xmlns:a16="http://schemas.microsoft.com/office/drawing/2014/main" id="{C6E28A7E-06F6-47BC-B9D8-8DA9BCEF2735}"/>
+                <a16:creationId xmlns:a16="http://schemas.microsoft.com/office/drawing/2014/main" id="{57ED931D-E41D-4146-8BEE-C7B713AD6607}"/>
               </a:ext>
             </a:extLst>
           </p:cNvPr>
@@ -1811,7 +1811,7 @@
           <p:cNvPr id="4" name="">
             <a:extLst xmlns:a="http://schemas.openxmlformats.org/drawingml/2006/main">
               <a:ext uri="{FF2B5EF4-FFF2-40B4-BE49-F238E27FC236}">
-                <a16:creationId xmlns:a16="http://schemas.microsoft.com/office/drawing/2014/main" id="{2880886A-ED79-4BD5-A50F-5DFB9706C4F4}"/>
+                <a16:creationId xmlns:a16="http://schemas.microsoft.com/office/drawing/2014/main" id="{5C0F9039-78FC-4FED-9403-42F55F462E43}"/>
               </a:ext>
             </a:extLst>
           </p:cNvPr>
@@ -1851,7 +1851,7 @@
                   <a:srgbClr val="536273"/>
                 </a:solidFill>
               </a:rPr>
-              <a:t>把課程規則變成一個可操作的個人排課系統</a:t>
+              <a:t>從 Google Calendar 到單檔 HTML 排課工具</a:t>
             </a:r>
           </a:p>
         </p:txBody>
@@ -1861,7 +1861,7 @@
           <p:cNvPr id="5" name="">
             <a:extLst xmlns:a="http://schemas.openxmlformats.org/drawingml/2006/main">
               <a:ext uri="{FF2B5EF4-FFF2-40B4-BE49-F238E27FC236}">
-                <a16:creationId xmlns:a16="http://schemas.microsoft.com/office/drawing/2014/main" id="{F4DAEEC2-46CC-47E9-B4D3-BDBDD3C9E138}"/>
+                <a16:creationId xmlns:a16="http://schemas.microsoft.com/office/drawing/2014/main" id="{05780DF1-FA96-4A2A-A110-319CFB4905EB}"/>
               </a:ext>
             </a:extLst>
           </p:cNvPr>
@@ -1896,7 +1896,7 @@
           <p:cNvPr id="6" name="">
             <a:extLst xmlns:a="http://schemas.openxmlformats.org/drawingml/2006/main">
               <a:ext uri="{FF2B5EF4-FFF2-40B4-BE49-F238E27FC236}">
-                <a16:creationId xmlns:a16="http://schemas.microsoft.com/office/drawing/2014/main" id="{B6B1EF9A-70CD-4C91-9B55-E2BC83639873}"/>
+                <a16:creationId xmlns:a16="http://schemas.microsoft.com/office/drawing/2014/main" id="{DA572161-217B-4817-B6E4-97D33EC39D98}"/>
               </a:ext>
             </a:extLst>
           </p:cNvPr>
@@ -1946,7 +1946,7 @@
           <p:cNvPr id="7" name="">
             <a:extLst xmlns:a="http://schemas.openxmlformats.org/drawingml/2006/main">
               <a:ext uri="{FF2B5EF4-FFF2-40B4-BE49-F238E27FC236}">
-                <a16:creationId xmlns:a16="http://schemas.microsoft.com/office/drawing/2014/main" id="{05463879-7094-43C3-BD7C-F72AE20134FD}"/>
+                <a16:creationId xmlns:a16="http://schemas.microsoft.com/office/drawing/2014/main" id="{E48A3221-9E8C-4E74-88C3-19E15DFC598C}"/>
               </a:ext>
             </a:extLst>
           </p:cNvPr>
@@ -2003,7 +2003,7 @@
                   <a:srgbClr val="111827"/>
                 </a:solidFill>
               </a:rPr>
-              <a:t>排課行事曆原型、欄位表、使用說明</a:t>
+              <a:t>Google Calendar 排程紀錄、HTML 排課工具、測試清單與 CSV 匯出</a:t>
             </a:r>
           </a:p>
         </p:txBody>
@@ -2011,7 +2011,7 @@
     </p:spTree>
     <p:extLst>
       <p:ext uri="{BB962C8B-B14F-4D97-AF65-F5344CB8AC3E}">
-        <p14:creationId xmlns:p14="http://schemas.microsoft.com/office/powerpoint/2010/main" val="1455174746"/>
+        <p14:creationId xmlns:p14="http://schemas.microsoft.com/office/powerpoint/2010/main" val="1684658751"/>
       </p:ext>
     </p:extLst>
   </p:cSld>
@@ -2042,7 +2042,7 @@
           <p:cNvPr id="12" name="">
             <a:extLst xmlns:a="http://schemas.openxmlformats.org/drawingml/2006/main">
               <a:ext uri="{FF2B5EF4-FFF2-40B4-BE49-F238E27FC236}">
-                <a16:creationId xmlns:a16="http://schemas.microsoft.com/office/drawing/2014/main" id="{FDC193AE-3DE0-47AA-8E6F-96B456304DE3}"/>
+                <a16:creationId xmlns:a16="http://schemas.microsoft.com/office/drawing/2014/main" id="{55047432-A371-444E-8C70-D9779C242B6D}"/>
               </a:ext>
             </a:extLst>
           </p:cNvPr>
@@ -2092,7 +2092,7 @@
           <p:cNvPr id="2" name="">
             <a:extLst xmlns:a="http://schemas.openxmlformats.org/drawingml/2006/main">
               <a:ext uri="{FF2B5EF4-FFF2-40B4-BE49-F238E27FC236}">
-                <a16:creationId xmlns:a16="http://schemas.microsoft.com/office/drawing/2014/main" id="{D5DF0E44-8FE5-4E4D-B040-52E582991FEF}"/>
+                <a16:creationId xmlns:a16="http://schemas.microsoft.com/office/drawing/2014/main" id="{93B6910C-0D04-4A41-8CEA-014F443C7D50}"/>
               </a:ext>
             </a:extLst>
           </p:cNvPr>
@@ -2142,7 +2142,7 @@
           <p:cNvPr id="3" name="">
             <a:extLst xmlns:a="http://schemas.openxmlformats.org/drawingml/2006/main">
               <a:ext uri="{FF2B5EF4-FFF2-40B4-BE49-F238E27FC236}">
-                <a16:creationId xmlns:a16="http://schemas.microsoft.com/office/drawing/2014/main" id="{8331DE30-700B-44D7-95F6-E61F93F0C5E8}"/>
+                <a16:creationId xmlns:a16="http://schemas.microsoft.com/office/drawing/2014/main" id="{F2297B4C-F5FD-4DF7-ACDF-92F337A76116}"/>
               </a:ext>
             </a:extLst>
           </p:cNvPr>
@@ -2192,7 +2192,7 @@
           <p:cNvPr id="4" name="">
             <a:extLst xmlns:a="http://schemas.openxmlformats.org/drawingml/2006/main">
               <a:ext uri="{FF2B5EF4-FFF2-40B4-BE49-F238E27FC236}">
-                <a16:creationId xmlns:a16="http://schemas.microsoft.com/office/drawing/2014/main" id="{5516F548-8B69-4DD5-913E-64DD6C2C9F2A}"/>
+                <a16:creationId xmlns:a16="http://schemas.microsoft.com/office/drawing/2014/main" id="{D9917277-D5D6-4DC8-827F-27E1EB1E26A9}"/>
               </a:ext>
             </a:extLst>
           </p:cNvPr>
@@ -2223,7 +2223,7 @@
           <p:cNvPr id="5" name="">
             <a:extLst xmlns:a="http://schemas.openxmlformats.org/drawingml/2006/main">
               <a:ext uri="{FF2B5EF4-FFF2-40B4-BE49-F238E27FC236}">
-                <a16:creationId xmlns:a16="http://schemas.microsoft.com/office/drawing/2014/main" id="{18878A50-5A96-40C2-8863-ADF46CAA3AE0}"/>
+                <a16:creationId xmlns:a16="http://schemas.microsoft.com/office/drawing/2014/main" id="{50369A83-4BD1-478E-AA43-2328C06DB35F}"/>
               </a:ext>
             </a:extLst>
           </p:cNvPr>
@@ -2273,7 +2273,7 @@
           <p:cNvPr id="6" name="">
             <a:extLst xmlns:a="http://schemas.openxmlformats.org/drawingml/2006/main">
               <a:ext uri="{FF2B5EF4-FFF2-40B4-BE49-F238E27FC236}">
-                <a16:creationId xmlns:a16="http://schemas.microsoft.com/office/drawing/2014/main" id="{B68C859D-36F9-4EBE-AFF6-195C7743D5D9}"/>
+                <a16:creationId xmlns:a16="http://schemas.microsoft.com/office/drawing/2014/main" id="{DA65BA07-1942-4C54-A684-B2C8697353C6}"/>
               </a:ext>
             </a:extLst>
           </p:cNvPr>
@@ -2313,7 +2313,7 @@
                   <a:srgbClr val="111827"/>
                 </a:solidFill>
               </a:rPr>
-              <a:t>• 把自然語言需求拆成資料欄位</a:t>
+              <a:t>• 用 @Google Workspace 協助建立與檢查 Calendar 行程</a:t>
             </a:r>
           </a:p>
         </p:txBody>
@@ -2323,7 +2323,7 @@
           <p:cNvPr id="7" name="">
             <a:extLst xmlns:a="http://schemas.openxmlformats.org/drawingml/2006/main">
               <a:ext uri="{FF2B5EF4-FFF2-40B4-BE49-F238E27FC236}">
-                <a16:creationId xmlns:a16="http://schemas.microsoft.com/office/drawing/2014/main" id="{F006C8D1-E5A7-49CA-B8F7-E71E5DFB9368}"/>
+                <a16:creationId xmlns:a16="http://schemas.microsoft.com/office/drawing/2014/main" id="{51E02C37-C2C7-4CA5-82EB-DF7DBF171AE6}"/>
               </a:ext>
             </a:extLst>
           </p:cNvPr>
@@ -2363,7 +2363,7 @@
                   <a:srgbClr val="111827"/>
                 </a:solidFill>
               </a:rPr>
-              <a:t>• 讓 Gemini 協助設計排課規則</a:t>
+              <a:t>• 把排課條件、衝堂規則與確認流程說清楚</a:t>
             </a:r>
           </a:p>
         </p:txBody>
@@ -2373,7 +2373,7 @@
           <p:cNvPr id="8" name="">
             <a:extLst xmlns:a="http://schemas.openxmlformats.org/drawingml/2006/main">
               <a:ext uri="{FF2B5EF4-FFF2-40B4-BE49-F238E27FC236}">
-                <a16:creationId xmlns:a16="http://schemas.microsoft.com/office/drawing/2014/main" id="{F947015E-E810-49BA-8D1C-99799B819407}"/>
+                <a16:creationId xmlns:a16="http://schemas.microsoft.com/office/drawing/2014/main" id="{D53A6A40-A7DB-4FD4-AC56-80DEC04A137B}"/>
               </a:ext>
             </a:extLst>
           </p:cNvPr>
@@ -2413,7 +2413,7 @@
                   <a:srgbClr val="111827"/>
                 </a:solidFill>
               </a:rPr>
-              <a:t>• 完成可維護的行事曆原型</a:t>
+              <a:t>• 用 Gemini 產出並測試本地端 HTML 排課工具</a:t>
             </a:r>
           </a:p>
         </p:txBody>
@@ -2423,7 +2423,7 @@
           <p:cNvPr id="9" name="">
             <a:extLst xmlns:a="http://schemas.openxmlformats.org/drawingml/2006/main">
               <a:ext uri="{FF2B5EF4-FFF2-40B4-BE49-F238E27FC236}">
-                <a16:creationId xmlns:a16="http://schemas.microsoft.com/office/drawing/2014/main" id="{2B282D3F-7D08-4169-BCAD-558994E55EF3}"/>
+                <a16:creationId xmlns:a16="http://schemas.microsoft.com/office/drawing/2014/main" id="{B60C87C2-429A-4649-BD83-2522AD8F1FD5}"/>
               </a:ext>
             </a:extLst>
           </p:cNvPr>
@@ -2460,7 +2460,7 @@
           <p:cNvPr id="10" name="">
             <a:extLst xmlns:a="http://schemas.openxmlformats.org/drawingml/2006/main">
               <a:ext uri="{FF2B5EF4-FFF2-40B4-BE49-F238E27FC236}">
-                <a16:creationId xmlns:a16="http://schemas.microsoft.com/office/drawing/2014/main" id="{BA2FBF71-DDCF-4411-A069-2719BDF5CD1A}"/>
+                <a16:creationId xmlns:a16="http://schemas.microsoft.com/office/drawing/2014/main" id="{77B631C3-2597-424D-933B-7BDABF8A718D}"/>
               </a:ext>
             </a:extLst>
           </p:cNvPr>
@@ -2510,7 +2510,7 @@
           <p:cNvPr id="11" name="">
             <a:extLst xmlns:a="http://schemas.openxmlformats.org/drawingml/2006/main">
               <a:ext uri="{FF2B5EF4-FFF2-40B4-BE49-F238E27FC236}">
-                <a16:creationId xmlns:a16="http://schemas.microsoft.com/office/drawing/2014/main" id="{0F979A2F-A319-4A56-B772-62A08882CA8D}"/>
+                <a16:creationId xmlns:a16="http://schemas.microsoft.com/office/drawing/2014/main" id="{AF5261C5-FCBD-47E7-AC4C-B6264B94AB53}"/>
               </a:ext>
             </a:extLst>
           </p:cNvPr>
@@ -2550,7 +2550,7 @@
                   <a:srgbClr val="111827"/>
                 </a:solidFill>
               </a:rPr>
-              <a:t>排課行事曆原型、欄位表、使用說明</a:t>
+              <a:t>Google Calendar 排程紀錄、HTML 排課工具、測試清單與 CSV 匯出</a:t>
             </a:r>
           </a:p>
         </p:txBody>
@@ -2558,7 +2558,7 @@
     </p:spTree>
     <p:extLst>
       <p:ext uri="{BB962C8B-B14F-4D97-AF65-F5344CB8AC3E}">
-        <p14:creationId xmlns:p14="http://schemas.microsoft.com/office/powerpoint/2010/main" val="1499462645"/>
+        <p14:creationId xmlns:p14="http://schemas.microsoft.com/office/powerpoint/2010/main" val="784526572"/>
       </p:ext>
     </p:extLst>
   </p:cSld>
@@ -2589,7 +2589,7 @@
           <p:cNvPr id="15" name="">
             <a:extLst xmlns:a="http://schemas.openxmlformats.org/drawingml/2006/main">
               <a:ext uri="{FF2B5EF4-FFF2-40B4-BE49-F238E27FC236}">
-                <a16:creationId xmlns:a16="http://schemas.microsoft.com/office/drawing/2014/main" id="{AFF9C657-4E9B-40D7-A644-23B1CFFD767B}"/>
+                <a16:creationId xmlns:a16="http://schemas.microsoft.com/office/drawing/2014/main" id="{4EE6A7C5-5CFA-4AAA-8DC9-6369CA9FE1FC}"/>
               </a:ext>
             </a:extLst>
           </p:cNvPr>
@@ -2639,7 +2639,7 @@
           <p:cNvPr id="2" name="">
             <a:extLst xmlns:a="http://schemas.openxmlformats.org/drawingml/2006/main">
               <a:ext uri="{FF2B5EF4-FFF2-40B4-BE49-F238E27FC236}">
-                <a16:creationId xmlns:a16="http://schemas.microsoft.com/office/drawing/2014/main" id="{AD209C1A-F945-4041-AA64-15AC5BF603FF}"/>
+                <a16:creationId xmlns:a16="http://schemas.microsoft.com/office/drawing/2014/main" id="{48168D97-B3AE-4E0D-92CD-51780C692CB7}"/>
               </a:ext>
             </a:extLst>
           </p:cNvPr>
@@ -2689,7 +2689,7 @@
           <p:cNvPr id="3" name="">
             <a:extLst xmlns:a="http://schemas.openxmlformats.org/drawingml/2006/main">
               <a:ext uri="{FF2B5EF4-FFF2-40B4-BE49-F238E27FC236}">
-                <a16:creationId xmlns:a16="http://schemas.microsoft.com/office/drawing/2014/main" id="{BB7073EA-860A-437D-9CC6-AFC0BDE5278C}"/>
+                <a16:creationId xmlns:a16="http://schemas.microsoft.com/office/drawing/2014/main" id="{86D2CC06-451B-473D-8EAC-C47237D141A4}"/>
               </a:ext>
             </a:extLst>
           </p:cNvPr>
@@ -2739,7 +2739,7 @@
           <p:cNvPr id="4" name="">
             <a:extLst xmlns:a="http://schemas.openxmlformats.org/drawingml/2006/main">
               <a:ext uri="{FF2B5EF4-FFF2-40B4-BE49-F238E27FC236}">
-                <a16:creationId xmlns:a16="http://schemas.microsoft.com/office/drawing/2014/main" id="{B9DA6AAD-03A1-4E70-A1AD-D639AE72A6A7}"/>
+                <a16:creationId xmlns:a16="http://schemas.microsoft.com/office/drawing/2014/main" id="{A16711FC-52CA-456F-8A1E-D64F67C37CB3}"/>
               </a:ext>
             </a:extLst>
           </p:cNvPr>
@@ -2770,7 +2770,7 @@
           <p:cNvPr id="5" name="">
             <a:extLst xmlns:a="http://schemas.openxmlformats.org/drawingml/2006/main">
               <a:ext uri="{FF2B5EF4-FFF2-40B4-BE49-F238E27FC236}">
-                <a16:creationId xmlns:a16="http://schemas.microsoft.com/office/drawing/2014/main" id="{94051AC3-C8D0-47D4-A264-C5A0AD2E626B}"/>
+                <a16:creationId xmlns:a16="http://schemas.microsoft.com/office/drawing/2014/main" id="{F007E07C-4385-473E-8968-AEE09A22A60F}"/>
               </a:ext>
             </a:extLst>
           </p:cNvPr>
@@ -2820,7 +2820,7 @@
           <p:cNvPr id="6" name="">
             <a:extLst xmlns:a="http://schemas.openxmlformats.org/drawingml/2006/main">
               <a:ext uri="{FF2B5EF4-FFF2-40B4-BE49-F238E27FC236}">
-                <a16:creationId xmlns:a16="http://schemas.microsoft.com/office/drawing/2014/main" id="{2E78916B-7098-41A3-B869-F13C55EA4890}"/>
+                <a16:creationId xmlns:a16="http://schemas.microsoft.com/office/drawing/2014/main" id="{9EDA6CF4-3B0C-4650-9B9B-C54327A6D9AB}"/>
               </a:ext>
             </a:extLst>
           </p:cNvPr>
@@ -2857,7 +2857,7 @@
           <p:cNvPr id="7" name="">
             <a:extLst xmlns:a="http://schemas.openxmlformats.org/drawingml/2006/main">
               <a:ext uri="{FF2B5EF4-FFF2-40B4-BE49-F238E27FC236}">
-                <a16:creationId xmlns:a16="http://schemas.microsoft.com/office/drawing/2014/main" id="{3AF2FAE5-5850-4F0E-A6FE-CB4A8C12BEA1}"/>
+                <a16:creationId xmlns:a16="http://schemas.microsoft.com/office/drawing/2014/main" id="{D1C61647-E00C-48DB-BF6B-B0714197E18B}"/>
               </a:ext>
             </a:extLst>
           </p:cNvPr>
@@ -2907,7 +2907,7 @@
           <p:cNvPr id="8" name="">
             <a:extLst xmlns:a="http://schemas.openxmlformats.org/drawingml/2006/main">
               <a:ext uri="{FF2B5EF4-FFF2-40B4-BE49-F238E27FC236}">
-                <a16:creationId xmlns:a16="http://schemas.microsoft.com/office/drawing/2014/main" id="{087FDFA3-7C37-4700-BE2D-AC4CCE179E52}"/>
+                <a16:creationId xmlns:a16="http://schemas.microsoft.com/office/drawing/2014/main" id="{3099BB9F-D040-46A1-90AD-3CEE3DBF791E}"/>
               </a:ext>
             </a:extLst>
           </p:cNvPr>
@@ -2947,7 +2947,7 @@
                   <a:srgbClr val="111827"/>
                 </a:solidFill>
               </a:rPr>
-              <a:t>先定義資料</a:t>
+              <a:t>先描述資料與規則，再要求 AI 執行</a:t>
             </a:r>
           </a:p>
         </p:txBody>
@@ -2957,7 +2957,7 @@
           <p:cNvPr id="9" name="">
             <a:extLst xmlns:a="http://schemas.openxmlformats.org/drawingml/2006/main">
               <a:ext uri="{FF2B5EF4-FFF2-40B4-BE49-F238E27FC236}">
-                <a16:creationId xmlns:a16="http://schemas.microsoft.com/office/drawing/2014/main" id="{FC96F947-B809-463A-BF8E-81C69059C07C}"/>
+                <a16:creationId xmlns:a16="http://schemas.microsoft.com/office/drawing/2014/main" id="{8397B51B-E6ED-4585-BB91-82AC7BE5201A}"/>
               </a:ext>
             </a:extLst>
           </p:cNvPr>
@@ -2992,7 +2992,7 @@
           <p:cNvPr id="10" name="">
             <a:extLst xmlns:a="http://schemas.openxmlformats.org/drawingml/2006/main">
               <a:ext uri="{FF2B5EF4-FFF2-40B4-BE49-F238E27FC236}">
-                <a16:creationId xmlns:a16="http://schemas.microsoft.com/office/drawing/2014/main" id="{CCB75BB4-9BBA-4329-8366-1BDC1B63CE23}"/>
+                <a16:creationId xmlns:a16="http://schemas.microsoft.com/office/drawing/2014/main" id="{DF56D34E-AE76-4BFE-824E-CF09B39F3A45}"/>
               </a:ext>
             </a:extLst>
           </p:cNvPr>
@@ -3042,7 +3042,7 @@
           <p:cNvPr id="11" name="">
             <a:extLst xmlns:a="http://schemas.openxmlformats.org/drawingml/2006/main">
               <a:ext uri="{FF2B5EF4-FFF2-40B4-BE49-F238E27FC236}">
-                <a16:creationId xmlns:a16="http://schemas.microsoft.com/office/drawing/2014/main" id="{DFA369B7-9E27-412B-9B0B-35FF6D0F499F}"/>
+                <a16:creationId xmlns:a16="http://schemas.microsoft.com/office/drawing/2014/main" id="{F53E2047-1BFC-46EC-9636-BD832BD2276E}"/>
               </a:ext>
             </a:extLst>
           </p:cNvPr>
@@ -3082,7 +3082,7 @@
                   <a:srgbClr val="111827"/>
                 </a:solidFill>
               </a:rPr>
-              <a:t>再定義規則</a:t>
+              <a:t>建立行程前先預覽、確認並檢查權限</a:t>
             </a:r>
           </a:p>
         </p:txBody>
@@ -3092,7 +3092,7 @@
           <p:cNvPr id="12" name="">
             <a:extLst xmlns:a="http://schemas.openxmlformats.org/drawingml/2006/main">
               <a:ext uri="{FF2B5EF4-FFF2-40B4-BE49-F238E27FC236}">
-                <a16:creationId xmlns:a16="http://schemas.microsoft.com/office/drawing/2014/main" id="{9F71AFA5-89DB-4AB6-9D43-0B3D6B305B22}"/>
+                <a16:creationId xmlns:a16="http://schemas.microsoft.com/office/drawing/2014/main" id="{ECE2BC5B-B084-4D95-838A-7CBB793319DE}"/>
               </a:ext>
             </a:extLst>
           </p:cNvPr>
@@ -3129,7 +3129,7 @@
           <p:cNvPr id="13" name="">
             <a:extLst xmlns:a="http://schemas.openxmlformats.org/drawingml/2006/main">
               <a:ext uri="{FF2B5EF4-FFF2-40B4-BE49-F238E27FC236}">
-                <a16:creationId xmlns:a16="http://schemas.microsoft.com/office/drawing/2014/main" id="{509F5CB7-BA71-42BE-8FE5-7EF6193BD8F2}"/>
+                <a16:creationId xmlns:a16="http://schemas.microsoft.com/office/drawing/2014/main" id="{170FED6E-7794-41A8-A785-3D9889CCF1C8}"/>
               </a:ext>
             </a:extLst>
           </p:cNvPr>
@@ -3179,7 +3179,7 @@
           <p:cNvPr id="14" name="">
             <a:extLst xmlns:a="http://schemas.openxmlformats.org/drawingml/2006/main">
               <a:ext uri="{FF2B5EF4-FFF2-40B4-BE49-F238E27FC236}">
-                <a16:creationId xmlns:a16="http://schemas.microsoft.com/office/drawing/2014/main" id="{C8DE0B56-A043-4308-BCB2-028EC85C0C1D}"/>
+                <a16:creationId xmlns:a16="http://schemas.microsoft.com/office/drawing/2014/main" id="{71AC4FD4-2F5F-4F7D-8087-7C3F5D968D6A}"/>
               </a:ext>
             </a:extLst>
           </p:cNvPr>
@@ -3219,7 +3219,7 @@
                   <a:srgbClr val="111827"/>
                 </a:solidFill>
               </a:rPr>
-              <a:t>最後才設計畫面</a:t>
+              <a:t>用驗證、刪除、localStorage 與 CSV 讓工具可用</a:t>
             </a:r>
           </a:p>
         </p:txBody>
@@ -3227,7 +3227,7 @@
     </p:spTree>
     <p:extLst>
       <p:ext uri="{BB962C8B-B14F-4D97-AF65-F5344CB8AC3E}">
-        <p14:creationId xmlns:p14="http://schemas.microsoft.com/office/powerpoint/2010/main" val="187802121"/>
+        <p14:creationId xmlns:p14="http://schemas.microsoft.com/office/powerpoint/2010/main" val="1804412737"/>
       </p:ext>
     </p:extLst>
   </p:cSld>
@@ -3258,7 +3258,7 @@
           <p:cNvPr id="21" name="">
             <a:extLst xmlns:a="http://schemas.openxmlformats.org/drawingml/2006/main">
               <a:ext uri="{FF2B5EF4-FFF2-40B4-BE49-F238E27FC236}">
-                <a16:creationId xmlns:a16="http://schemas.microsoft.com/office/drawing/2014/main" id="{62DAA8FE-627C-48C9-A809-2E002C251D3F}"/>
+                <a16:creationId xmlns:a16="http://schemas.microsoft.com/office/drawing/2014/main" id="{93323F31-E7F1-4F10-8DDA-A23AB41CB4C4}"/>
               </a:ext>
             </a:extLst>
           </p:cNvPr>
@@ -3308,7 +3308,7 @@
           <p:cNvPr id="2" name="">
             <a:extLst xmlns:a="http://schemas.openxmlformats.org/drawingml/2006/main">
               <a:ext uri="{FF2B5EF4-FFF2-40B4-BE49-F238E27FC236}">
-                <a16:creationId xmlns:a16="http://schemas.microsoft.com/office/drawing/2014/main" id="{565CFCAD-F70C-4AC0-9FC4-569565D36CF8}"/>
+                <a16:creationId xmlns:a16="http://schemas.microsoft.com/office/drawing/2014/main" id="{EB6876E2-57B9-4C4A-8F2F-9062B0D7E86E}"/>
               </a:ext>
             </a:extLst>
           </p:cNvPr>
@@ -3358,7 +3358,7 @@
           <p:cNvPr id="3" name="">
             <a:extLst xmlns:a="http://schemas.openxmlformats.org/drawingml/2006/main">
               <a:ext uri="{FF2B5EF4-FFF2-40B4-BE49-F238E27FC236}">
-                <a16:creationId xmlns:a16="http://schemas.microsoft.com/office/drawing/2014/main" id="{932225D7-A15E-49E3-BC2D-3515C623456C}"/>
+                <a16:creationId xmlns:a16="http://schemas.microsoft.com/office/drawing/2014/main" id="{58EF1396-E1DB-4B87-A349-4AEE9A231519}"/>
               </a:ext>
             </a:extLst>
           </p:cNvPr>
@@ -3408,7 +3408,7 @@
           <p:cNvPr id="4" name="">
             <a:extLst xmlns:a="http://schemas.openxmlformats.org/drawingml/2006/main">
               <a:ext uri="{FF2B5EF4-FFF2-40B4-BE49-F238E27FC236}">
-                <a16:creationId xmlns:a16="http://schemas.microsoft.com/office/drawing/2014/main" id="{07C4CF53-5A27-42D3-BCFB-9EC170811722}"/>
+                <a16:creationId xmlns:a16="http://schemas.microsoft.com/office/drawing/2014/main" id="{DDA8B8D5-4266-4DC8-BA64-3212DEEAA515}"/>
               </a:ext>
             </a:extLst>
           </p:cNvPr>
@@ -3439,7 +3439,7 @@
           <p:cNvPr id="5" name="">
             <a:extLst xmlns:a="http://schemas.openxmlformats.org/drawingml/2006/main">
               <a:ext uri="{FF2B5EF4-FFF2-40B4-BE49-F238E27FC236}">
-                <a16:creationId xmlns:a16="http://schemas.microsoft.com/office/drawing/2014/main" id="{47777399-2B42-40FE-A585-87DF191F3BE1}"/>
+                <a16:creationId xmlns:a16="http://schemas.microsoft.com/office/drawing/2014/main" id="{C4B0EF4E-F170-46A1-BCD7-FB51C44F0B7F}"/>
               </a:ext>
             </a:extLst>
           </p:cNvPr>
@@ -3489,7 +3489,7 @@
           <p:cNvPr id="6" name="">
             <a:extLst xmlns:a="http://schemas.openxmlformats.org/drawingml/2006/main">
               <a:ext uri="{FF2B5EF4-FFF2-40B4-BE49-F238E27FC236}">
-                <a16:creationId xmlns:a16="http://schemas.microsoft.com/office/drawing/2014/main" id="{8061766B-D601-4EE5-81D1-8B91284C2CAE}"/>
+                <a16:creationId xmlns:a16="http://schemas.microsoft.com/office/drawing/2014/main" id="{27DBD297-E34C-4A03-ACE6-D441C7C73542}"/>
               </a:ext>
             </a:extLst>
           </p:cNvPr>
@@ -3526,7 +3526,7 @@
           <p:cNvPr id="7" name="">
             <a:extLst xmlns:a="http://schemas.openxmlformats.org/drawingml/2006/main">
               <a:ext uri="{FF2B5EF4-FFF2-40B4-BE49-F238E27FC236}">
-                <a16:creationId xmlns:a16="http://schemas.microsoft.com/office/drawing/2014/main" id="{BB0864A5-3316-47E1-A1B9-2B597E11549E}"/>
+                <a16:creationId xmlns:a16="http://schemas.microsoft.com/office/drawing/2014/main" id="{DCEF7D20-46F5-419B-8136-698935904ED9}"/>
               </a:ext>
             </a:extLst>
           </p:cNvPr>
@@ -3576,7 +3576,7 @@
           <p:cNvPr id="8" name="">
             <a:extLst xmlns:a="http://schemas.openxmlformats.org/drawingml/2006/main">
               <a:ext uri="{FF2B5EF4-FFF2-40B4-BE49-F238E27FC236}">
-                <a16:creationId xmlns:a16="http://schemas.microsoft.com/office/drawing/2014/main" id="{70542A56-E07D-4C98-91AD-0561054D514D}"/>
+                <a16:creationId xmlns:a16="http://schemas.microsoft.com/office/drawing/2014/main" id="{78FF64CC-7720-4313-9AA3-EC58655DC6C6}"/>
               </a:ext>
             </a:extLst>
           </p:cNvPr>
@@ -3616,7 +3616,7 @@
                   <a:srgbClr val="111827"/>
                 </a:solidFill>
               </a:rPr>
-              <a:t>列出課程、時段、地點</a:t>
+              <a:t>確認 Google Workspace 擴充功能</a:t>
             </a:r>
           </a:p>
         </p:txBody>
@@ -3626,7 +3626,7 @@
           <p:cNvPr id="9" name="">
             <a:extLst xmlns:a="http://schemas.openxmlformats.org/drawingml/2006/main">
               <a:ext uri="{FF2B5EF4-FFF2-40B4-BE49-F238E27FC236}">
-                <a16:creationId xmlns:a16="http://schemas.microsoft.com/office/drawing/2014/main" id="{0A9A87AC-E760-4A78-AEE6-39F74E16E530}"/>
+                <a16:creationId xmlns:a16="http://schemas.microsoft.com/office/drawing/2014/main" id="{81DF3AE3-AB22-4B3D-886B-4DF286CD33B3}"/>
               </a:ext>
             </a:extLst>
           </p:cNvPr>
@@ -3663,7 +3663,7 @@
           <p:cNvPr id="10" name="">
             <a:extLst xmlns:a="http://schemas.openxmlformats.org/drawingml/2006/main">
               <a:ext uri="{FF2B5EF4-FFF2-40B4-BE49-F238E27FC236}">
-                <a16:creationId xmlns:a16="http://schemas.microsoft.com/office/drawing/2014/main" id="{54FFB33F-7B3E-49FA-AF38-0590D135D930}"/>
+                <a16:creationId xmlns:a16="http://schemas.microsoft.com/office/drawing/2014/main" id="{40D6909A-2688-4D79-B3AB-BAC79C9CC93E}"/>
               </a:ext>
             </a:extLst>
           </p:cNvPr>
@@ -3713,7 +3713,7 @@
           <p:cNvPr id="11" name="">
             <a:extLst xmlns:a="http://schemas.openxmlformats.org/drawingml/2006/main">
               <a:ext uri="{FF2B5EF4-FFF2-40B4-BE49-F238E27FC236}">
-                <a16:creationId xmlns:a16="http://schemas.microsoft.com/office/drawing/2014/main" id="{C19ECBDF-FA1C-4435-A174-9D81109127CF}"/>
+                <a16:creationId xmlns:a16="http://schemas.microsoft.com/office/drawing/2014/main" id="{CE75BE77-E91D-4ED4-AF45-9EE6F3A53064}"/>
               </a:ext>
             </a:extLst>
           </p:cNvPr>
@@ -3753,7 +3753,7 @@
                   <a:srgbClr val="111827"/>
                 </a:solidFill>
               </a:rPr>
-              <a:t>請 Gemini 找出衝堂條件</a:t>
+              <a:t>建立單一 Calendar 課程</a:t>
             </a:r>
           </a:p>
         </p:txBody>
@@ -3763,7 +3763,7 @@
           <p:cNvPr id="12" name="">
             <a:extLst xmlns:a="http://schemas.openxmlformats.org/drawingml/2006/main">
               <a:ext uri="{FF2B5EF4-FFF2-40B4-BE49-F238E27FC236}">
-                <a16:creationId xmlns:a16="http://schemas.microsoft.com/office/drawing/2014/main" id="{536D39E6-AE89-45BC-972C-A6266DE35EA7}"/>
+                <a16:creationId xmlns:a16="http://schemas.microsoft.com/office/drawing/2014/main" id="{4E6F0B85-7DCD-4427-942E-7F08C46C31F2}"/>
               </a:ext>
             </a:extLst>
           </p:cNvPr>
@@ -3800,7 +3800,7 @@
           <p:cNvPr id="13" name="">
             <a:extLst xmlns:a="http://schemas.openxmlformats.org/drawingml/2006/main">
               <a:ext uri="{FF2B5EF4-FFF2-40B4-BE49-F238E27FC236}">
-                <a16:creationId xmlns:a16="http://schemas.microsoft.com/office/drawing/2014/main" id="{5B12966A-7E4A-45C6-BAF9-3B7389E08BB1}"/>
+                <a16:creationId xmlns:a16="http://schemas.microsoft.com/office/drawing/2014/main" id="{A80A07D5-870B-4EEB-98B1-06F17F14985C}"/>
               </a:ext>
             </a:extLst>
           </p:cNvPr>
@@ -3850,7 +3850,7 @@
           <p:cNvPr id="14" name="">
             <a:extLst xmlns:a="http://schemas.openxmlformats.org/drawingml/2006/main">
               <a:ext uri="{FF2B5EF4-FFF2-40B4-BE49-F238E27FC236}">
-                <a16:creationId xmlns:a16="http://schemas.microsoft.com/office/drawing/2014/main" id="{7A24C236-EB34-4981-97DB-7D313A411601}"/>
+                <a16:creationId xmlns:a16="http://schemas.microsoft.com/office/drawing/2014/main" id="{BA578B4A-BDB7-4071-8846-58AED82616AD}"/>
               </a:ext>
             </a:extLst>
           </p:cNvPr>
@@ -3890,7 +3890,7 @@
                   <a:srgbClr val="111827"/>
                 </a:solidFill>
               </a:rPr>
-              <a:t>建立 Google Sheet 欄位</a:t>
+              <a:t>提供條件並避開既有衝堂</a:t>
             </a:r>
           </a:p>
         </p:txBody>
@@ -3900,7 +3900,7 @@
           <p:cNvPr id="15" name="">
             <a:extLst xmlns:a="http://schemas.openxmlformats.org/drawingml/2006/main">
               <a:ext uri="{FF2B5EF4-FFF2-40B4-BE49-F238E27FC236}">
-                <a16:creationId xmlns:a16="http://schemas.microsoft.com/office/drawing/2014/main" id="{BC6753AF-168A-4052-8D14-0D080280F842}"/>
+                <a16:creationId xmlns:a16="http://schemas.microsoft.com/office/drawing/2014/main" id="{E85391A3-E4D0-48CC-9064-06836BA72FC1}"/>
               </a:ext>
             </a:extLst>
           </p:cNvPr>
@@ -3937,7 +3937,7 @@
           <p:cNvPr id="16" name="">
             <a:extLst xmlns:a="http://schemas.openxmlformats.org/drawingml/2006/main">
               <a:ext uri="{FF2B5EF4-FFF2-40B4-BE49-F238E27FC236}">
-                <a16:creationId xmlns:a16="http://schemas.microsoft.com/office/drawing/2014/main" id="{1F207960-3859-45C5-B28C-3D7E35EB9526}"/>
+                <a16:creationId xmlns:a16="http://schemas.microsoft.com/office/drawing/2014/main" id="{C50A6E6D-40C0-4034-95F7-DDAD3D0A4820}"/>
               </a:ext>
             </a:extLst>
           </p:cNvPr>
@@ -3987,7 +3987,7 @@
           <p:cNvPr id="17" name="">
             <a:extLst xmlns:a="http://schemas.openxmlformats.org/drawingml/2006/main">
               <a:ext uri="{FF2B5EF4-FFF2-40B4-BE49-F238E27FC236}">
-                <a16:creationId xmlns:a16="http://schemas.microsoft.com/office/drawing/2014/main" id="{D008C820-C96D-4E54-A013-7AB683368985}"/>
+                <a16:creationId xmlns:a16="http://schemas.microsoft.com/office/drawing/2014/main" id="{74D4D8AF-8E32-4DA4-A415-DCB31AB7153F}"/>
               </a:ext>
             </a:extLst>
           </p:cNvPr>
@@ -4027,7 +4027,7 @@
                   <a:srgbClr val="111827"/>
                 </a:solidFill>
               </a:rPr>
-              <a:t>生成排課邏輯與提示詞</a:t>
+              <a:t>生成單檔 HTML 排課工具</a:t>
             </a:r>
           </a:p>
         </p:txBody>
@@ -4037,7 +4037,7 @@
           <p:cNvPr id="18" name="">
             <a:extLst xmlns:a="http://schemas.openxmlformats.org/drawingml/2006/main">
               <a:ext uri="{FF2B5EF4-FFF2-40B4-BE49-F238E27FC236}">
-                <a16:creationId xmlns:a16="http://schemas.microsoft.com/office/drawing/2014/main" id="{CEA5E92C-1B9F-4AD7-B79B-45C8133BBEFA}"/>
+                <a16:creationId xmlns:a16="http://schemas.microsoft.com/office/drawing/2014/main" id="{E22F7919-5464-4CFE-8E5D-ADDD9C6F76F8}"/>
               </a:ext>
             </a:extLst>
           </p:cNvPr>
@@ -4074,7 +4074,7 @@
           <p:cNvPr id="19" name="">
             <a:extLst xmlns:a="http://schemas.openxmlformats.org/drawingml/2006/main">
               <a:ext uri="{FF2B5EF4-FFF2-40B4-BE49-F238E27FC236}">
-                <a16:creationId xmlns:a16="http://schemas.microsoft.com/office/drawing/2014/main" id="{B180AFF2-3A11-406C-92F3-3C46892CB554}"/>
+                <a16:creationId xmlns:a16="http://schemas.microsoft.com/office/drawing/2014/main" id="{EF7538C9-E0DD-4F50-B13C-7B5EEBD22F9E}"/>
               </a:ext>
             </a:extLst>
           </p:cNvPr>
@@ -4124,7 +4124,7 @@
           <p:cNvPr id="20" name="">
             <a:extLst xmlns:a="http://schemas.openxmlformats.org/drawingml/2006/main">
               <a:ext uri="{FF2B5EF4-FFF2-40B4-BE49-F238E27FC236}">
-                <a16:creationId xmlns:a16="http://schemas.microsoft.com/office/drawing/2014/main" id="{D0055340-CA76-402C-B034-7C9E1C866834}"/>
+                <a16:creationId xmlns:a16="http://schemas.microsoft.com/office/drawing/2014/main" id="{075A45E7-E94F-4188-87B7-FA93FDD0A9A3}"/>
               </a:ext>
             </a:extLst>
           </p:cNvPr>
@@ -4164,7 +4164,7 @@
                   <a:srgbClr val="111827"/>
                 </a:solidFill>
               </a:rPr>
-              <a:t>人工檢查結果</a:t>
+              <a:t>加入驗證、刪除與 CSV 測試</a:t>
             </a:r>
           </a:p>
         </p:txBody>
@@ -4172,7 +4172,7 @@
     </p:spTree>
     <p:extLst>
       <p:ext uri="{BB962C8B-B14F-4D97-AF65-F5344CB8AC3E}">
-        <p14:creationId xmlns:p14="http://schemas.microsoft.com/office/powerpoint/2010/main" val="185971378"/>
+        <p14:creationId xmlns:p14="http://schemas.microsoft.com/office/powerpoint/2010/main" val="1415140897"/>
       </p:ext>
     </p:extLst>
   </p:cSld>
@@ -4203,7 +4203,7 @@
           <p:cNvPr id="8" name="">
             <a:extLst xmlns:a="http://schemas.openxmlformats.org/drawingml/2006/main">
               <a:ext uri="{FF2B5EF4-FFF2-40B4-BE49-F238E27FC236}">
-                <a16:creationId xmlns:a16="http://schemas.microsoft.com/office/drawing/2014/main" id="{6AE3AA39-562E-4E3C-8FDD-E2A7D7355503}"/>
+                <a16:creationId xmlns:a16="http://schemas.microsoft.com/office/drawing/2014/main" id="{908677D6-D3D3-4F05-861A-83CC3323AF44}"/>
               </a:ext>
             </a:extLst>
           </p:cNvPr>
@@ -4253,7 +4253,7 @@
           <p:cNvPr id="2" name="">
             <a:extLst xmlns:a="http://schemas.openxmlformats.org/drawingml/2006/main">
               <a:ext uri="{FF2B5EF4-FFF2-40B4-BE49-F238E27FC236}">
-                <a16:creationId xmlns:a16="http://schemas.microsoft.com/office/drawing/2014/main" id="{56674CD8-9234-47A2-A708-B4615FEB8970}"/>
+                <a16:creationId xmlns:a16="http://schemas.microsoft.com/office/drawing/2014/main" id="{1E382177-FCA2-45F2-B4FA-DFB8C726AD25}"/>
               </a:ext>
             </a:extLst>
           </p:cNvPr>
@@ -4303,7 +4303,7 @@
           <p:cNvPr id="3" name="">
             <a:extLst xmlns:a="http://schemas.openxmlformats.org/drawingml/2006/main">
               <a:ext uri="{FF2B5EF4-FFF2-40B4-BE49-F238E27FC236}">
-                <a16:creationId xmlns:a16="http://schemas.microsoft.com/office/drawing/2014/main" id="{E5979EF0-27D2-4031-B629-67A07F2A5AF9}"/>
+                <a16:creationId xmlns:a16="http://schemas.microsoft.com/office/drawing/2014/main" id="{4461FCBA-70F9-4C0B-9B37-360948E8E165}"/>
               </a:ext>
             </a:extLst>
           </p:cNvPr>
@@ -4353,7 +4353,7 @@
           <p:cNvPr id="4" name="">
             <a:extLst xmlns:a="http://schemas.openxmlformats.org/drawingml/2006/main">
               <a:ext uri="{FF2B5EF4-FFF2-40B4-BE49-F238E27FC236}">
-                <a16:creationId xmlns:a16="http://schemas.microsoft.com/office/drawing/2014/main" id="{22415764-676F-4CF5-9E85-FB5EBC94113E}"/>
+                <a16:creationId xmlns:a16="http://schemas.microsoft.com/office/drawing/2014/main" id="{F25E89DA-E70D-4222-9300-2BAE26D73D92}"/>
               </a:ext>
             </a:extLst>
           </p:cNvPr>
@@ -4384,7 +4384,7 @@
           <p:cNvPr id="5" name="">
             <a:extLst xmlns:a="http://schemas.openxmlformats.org/drawingml/2006/main">
               <a:ext uri="{FF2B5EF4-FFF2-40B4-BE49-F238E27FC236}">
-                <a16:creationId xmlns:a16="http://schemas.microsoft.com/office/drawing/2014/main" id="{299987F4-AA56-4D30-BA07-480EB1BA6095}"/>
+                <a16:creationId xmlns:a16="http://schemas.microsoft.com/office/drawing/2014/main" id="{118D0499-FFEA-436E-90F4-E1CA118A1BC2}"/>
               </a:ext>
             </a:extLst>
           </p:cNvPr>
@@ -4419,7 +4419,7 @@
           <p:cNvPr id="6" name="">
             <a:extLst xmlns:a="http://schemas.openxmlformats.org/drawingml/2006/main">
               <a:ext uri="{FF2B5EF4-FFF2-40B4-BE49-F238E27FC236}">
-                <a16:creationId xmlns:a16="http://schemas.microsoft.com/office/drawing/2014/main" id="{8164F7E4-2163-468D-9B0A-60B0D96CE6B3}"/>
+                <a16:creationId xmlns:a16="http://schemas.microsoft.com/office/drawing/2014/main" id="{CCAC7E4F-26CA-4C19-AD05-EF7A33E7F0EA}"/>
               </a:ext>
             </a:extLst>
           </p:cNvPr>
@@ -4459,7 +4459,7 @@
                   <a:srgbClr val="FFFFFF"/>
                 </a:solidFill>
               </a:rPr>
-              <a:t>請幫我設計一個排課行事曆。先詢問必要條件，再建立課程、日期、時間、地點、教師、班級與備註欄位，最後提出避免衝堂的規則。不要直接假設未知資訊。</a:t>
+              <a:t>請幫我建立下週的課程行事曆：AI 基礎工具應用實務，下週一到週三，每天下午 2:00 到 4:00。請先列出三個事件供我確認日期、時間與時區，再協助加入 Google Calendar。</a:t>
             </a:r>
           </a:p>
         </p:txBody>
@@ -4469,7 +4469,7 @@
           <p:cNvPr id="7" name="">
             <a:extLst xmlns:a="http://schemas.openxmlformats.org/drawingml/2006/main">
               <a:ext uri="{FF2B5EF4-FFF2-40B4-BE49-F238E27FC236}">
-                <a16:creationId xmlns:a16="http://schemas.microsoft.com/office/drawing/2014/main" id="{80CA1C19-A988-4CDD-8F3D-83071CB2D264}"/>
+                <a16:creationId xmlns:a16="http://schemas.microsoft.com/office/drawing/2014/main" id="{B22AB3DC-2285-49F4-9B45-B1CAE6EBFE79}"/>
               </a:ext>
             </a:extLst>
           </p:cNvPr>
@@ -4517,7 +4517,7 @@
     </p:spTree>
     <p:extLst>
       <p:ext uri="{BB962C8B-B14F-4D97-AF65-F5344CB8AC3E}">
-        <p14:creationId xmlns:p14="http://schemas.microsoft.com/office/powerpoint/2010/main" val="272507936"/>
+        <p14:creationId xmlns:p14="http://schemas.microsoft.com/office/powerpoint/2010/main" val="986212361"/>
       </p:ext>
     </p:extLst>
   </p:cSld>
@@ -4548,7 +4548,7 @@
           <p:cNvPr id="14" name="">
             <a:extLst xmlns:a="http://schemas.openxmlformats.org/drawingml/2006/main">
               <a:ext uri="{FF2B5EF4-FFF2-40B4-BE49-F238E27FC236}">
-                <a16:creationId xmlns:a16="http://schemas.microsoft.com/office/drawing/2014/main" id="{506D9273-CEC1-41DF-A6F5-BD2CF82824AB}"/>
+                <a16:creationId xmlns:a16="http://schemas.microsoft.com/office/drawing/2014/main" id="{0385313E-F5CA-4F2B-8E76-0361B22322CB}"/>
               </a:ext>
             </a:extLst>
           </p:cNvPr>
@@ -4598,7 +4598,7 @@
           <p:cNvPr id="2" name="">
             <a:extLst xmlns:a="http://schemas.openxmlformats.org/drawingml/2006/main">
               <a:ext uri="{FF2B5EF4-FFF2-40B4-BE49-F238E27FC236}">
-                <a16:creationId xmlns:a16="http://schemas.microsoft.com/office/drawing/2014/main" id="{070D4849-C66E-43A7-BFDF-CD52870740DC}"/>
+                <a16:creationId xmlns:a16="http://schemas.microsoft.com/office/drawing/2014/main" id="{69185841-B901-40CB-8453-08C54CBE426A}"/>
               </a:ext>
             </a:extLst>
           </p:cNvPr>
@@ -4648,7 +4648,7 @@
           <p:cNvPr id="3" name="">
             <a:extLst xmlns:a="http://schemas.openxmlformats.org/drawingml/2006/main">
               <a:ext uri="{FF2B5EF4-FFF2-40B4-BE49-F238E27FC236}">
-                <a16:creationId xmlns:a16="http://schemas.microsoft.com/office/drawing/2014/main" id="{B785E50F-BD3A-4586-A7C8-07CE1A13D066}"/>
+                <a16:creationId xmlns:a16="http://schemas.microsoft.com/office/drawing/2014/main" id="{8AF9AEAA-C212-465C-BA4C-B098A1D7CCB0}"/>
               </a:ext>
             </a:extLst>
           </p:cNvPr>
@@ -4698,7 +4698,7 @@
           <p:cNvPr id="4" name="">
             <a:extLst xmlns:a="http://schemas.openxmlformats.org/drawingml/2006/main">
               <a:ext uri="{FF2B5EF4-FFF2-40B4-BE49-F238E27FC236}">
-                <a16:creationId xmlns:a16="http://schemas.microsoft.com/office/drawing/2014/main" id="{8E69416D-FDD5-48AC-BA63-0F9EC095E317}"/>
+                <a16:creationId xmlns:a16="http://schemas.microsoft.com/office/drawing/2014/main" id="{39CF9F5F-D07D-4DA0-98A2-2ADB90A6D9CA}"/>
               </a:ext>
             </a:extLst>
           </p:cNvPr>
@@ -4729,7 +4729,7 @@
           <p:cNvPr id="5" name="">
             <a:extLst xmlns:a="http://schemas.openxmlformats.org/drawingml/2006/main">
               <a:ext uri="{FF2B5EF4-FFF2-40B4-BE49-F238E27FC236}">
-                <a16:creationId xmlns:a16="http://schemas.microsoft.com/office/drawing/2014/main" id="{46737B0D-007D-4900-BD14-96A150936588}"/>
+                <a16:creationId xmlns:a16="http://schemas.microsoft.com/office/drawing/2014/main" id="{3CB51152-3456-47E7-80A3-E9F6598082CC}"/>
               </a:ext>
             </a:extLst>
           </p:cNvPr>
@@ -4779,7 +4779,7 @@
           <p:cNvPr id="6" name="">
             <a:extLst xmlns:a="http://schemas.openxmlformats.org/drawingml/2006/main">
               <a:ext uri="{FF2B5EF4-FFF2-40B4-BE49-F238E27FC236}">
-                <a16:creationId xmlns:a16="http://schemas.microsoft.com/office/drawing/2014/main" id="{34ACD637-62BC-46C4-A5F1-999CB11EA624}"/>
+                <a16:creationId xmlns:a16="http://schemas.microsoft.com/office/drawing/2014/main" id="{3D5E9D90-BCF4-492F-B14E-3E260F1BBF22}"/>
               </a:ext>
             </a:extLst>
           </p:cNvPr>
@@ -4814,7 +4814,7 @@
           <p:cNvPr id="7" name="">
             <a:extLst xmlns:a="http://schemas.openxmlformats.org/drawingml/2006/main">
               <a:ext uri="{FF2B5EF4-FFF2-40B4-BE49-F238E27FC236}">
-                <a16:creationId xmlns:a16="http://schemas.microsoft.com/office/drawing/2014/main" id="{BFBC71A2-6D6A-44F3-8135-D01C61456555}"/>
+                <a16:creationId xmlns:a16="http://schemas.microsoft.com/office/drawing/2014/main" id="{497B4D96-120F-44EA-9C55-BCC3102BD215}"/>
               </a:ext>
             </a:extLst>
           </p:cNvPr>
@@ -4854,7 +4854,7 @@
                   <a:srgbClr val="111827"/>
                 </a:solidFill>
               </a:rPr>
-              <a:t>建立自己的每週課程表，加入至少 5 門課、3 種時段與 2 個可能衝堂的情況。</a:t>
+              <a:t>完成一個 Calendar 排程案例與一個可在瀏覽器開啟的 HTML 排課工具，測試新增、刪除、錯誤時間、重新整理與 CSV 匯出。</a:t>
             </a:r>
           </a:p>
         </p:txBody>
@@ -4864,7 +4864,7 @@
           <p:cNvPr id="8" name="">
             <a:extLst xmlns:a="http://schemas.openxmlformats.org/drawingml/2006/main">
               <a:ext uri="{FF2B5EF4-FFF2-40B4-BE49-F238E27FC236}">
-                <a16:creationId xmlns:a16="http://schemas.microsoft.com/office/drawing/2014/main" id="{472E90A6-DAF4-4D19-9166-F96ED1DD2B39}"/>
+                <a16:creationId xmlns:a16="http://schemas.microsoft.com/office/drawing/2014/main" id="{7D2FBC11-BD04-4841-AF58-4ABE202F6E47}"/>
               </a:ext>
             </a:extLst>
           </p:cNvPr>
@@ -4901,7 +4901,7 @@
           <p:cNvPr id="9" name="">
             <a:extLst xmlns:a="http://schemas.openxmlformats.org/drawingml/2006/main">
               <a:ext uri="{FF2B5EF4-FFF2-40B4-BE49-F238E27FC236}">
-                <a16:creationId xmlns:a16="http://schemas.microsoft.com/office/drawing/2014/main" id="{18A45D93-8DE3-4096-9311-37B09895F589}"/>
+                <a16:creationId xmlns:a16="http://schemas.microsoft.com/office/drawing/2014/main" id="{AD477CC6-2D35-44AF-919A-C539A9BC076E}"/>
               </a:ext>
             </a:extLst>
           </p:cNvPr>
@@ -4951,7 +4951,7 @@
           <p:cNvPr id="10" name="">
             <a:extLst xmlns:a="http://schemas.openxmlformats.org/drawingml/2006/main">
               <a:ext uri="{FF2B5EF4-FFF2-40B4-BE49-F238E27FC236}">
-                <a16:creationId xmlns:a16="http://schemas.microsoft.com/office/drawing/2014/main" id="{38B0B99E-1DEC-4B23-B9F1-7A4B345E9C67}"/>
+                <a16:creationId xmlns:a16="http://schemas.microsoft.com/office/drawing/2014/main" id="{D3627AD3-5085-4B07-9588-0F885B4DB96F}"/>
               </a:ext>
             </a:extLst>
           </p:cNvPr>
@@ -5001,7 +5001,7 @@
           <p:cNvPr id="11" name="">
             <a:extLst xmlns:a="http://schemas.openxmlformats.org/drawingml/2006/main">
               <a:ext uri="{FF2B5EF4-FFF2-40B4-BE49-F238E27FC236}">
-                <a16:creationId xmlns:a16="http://schemas.microsoft.com/office/drawing/2014/main" id="{78A99121-01D2-4704-8A2A-DAD8359D24E7}"/>
+                <a16:creationId xmlns:a16="http://schemas.microsoft.com/office/drawing/2014/main" id="{011B6A41-3925-47EE-9AAB-406956FD0BD7}"/>
               </a:ext>
             </a:extLst>
           </p:cNvPr>
@@ -5051,7 +5051,7 @@
           <p:cNvPr id="12" name="">
             <a:extLst xmlns:a="http://schemas.openxmlformats.org/drawingml/2006/main">
               <a:ext uri="{FF2B5EF4-FFF2-40B4-BE49-F238E27FC236}">
-                <a16:creationId xmlns:a16="http://schemas.microsoft.com/office/drawing/2014/main" id="{E9D1752A-2C0E-4324-9293-E501F0A53154}"/>
+                <a16:creationId xmlns:a16="http://schemas.microsoft.com/office/drawing/2014/main" id="{F4469C58-9107-4172-90DC-79E138F236D8}"/>
               </a:ext>
             </a:extLst>
           </p:cNvPr>
@@ -5101,7 +5101,7 @@
           <p:cNvPr id="13" name="">
             <a:extLst xmlns:a="http://schemas.openxmlformats.org/drawingml/2006/main">
               <a:ext uri="{FF2B5EF4-FFF2-40B4-BE49-F238E27FC236}">
-                <a16:creationId xmlns:a16="http://schemas.microsoft.com/office/drawing/2014/main" id="{92AAB507-29C2-4565-BE2B-D1C28AEE0704}"/>
+                <a16:creationId xmlns:a16="http://schemas.microsoft.com/office/drawing/2014/main" id="{DD2696E7-3C4D-402C-99F0-625BEBB10E1E}"/>
               </a:ext>
             </a:extLst>
           </p:cNvPr>
@@ -5149,7 +5149,7 @@
     </p:spTree>
     <p:extLst>
       <p:ext uri="{BB962C8B-B14F-4D97-AF65-F5344CB8AC3E}">
-        <p14:creationId xmlns:p14="http://schemas.microsoft.com/office/powerpoint/2010/main" val="1091725747"/>
+        <p14:creationId xmlns:p14="http://schemas.microsoft.com/office/powerpoint/2010/main" val="1325622850"/>
       </p:ext>
     </p:extLst>
   </p:cSld>
@@ -5180,7 +5180,7 @@
           <p:cNvPr id="16" name="">
             <a:extLst xmlns:a="http://schemas.openxmlformats.org/drawingml/2006/main">
               <a:ext uri="{FF2B5EF4-FFF2-40B4-BE49-F238E27FC236}">
-                <a16:creationId xmlns:a16="http://schemas.microsoft.com/office/drawing/2014/main" id="{93E213F3-0449-46C0-8B59-AB7764D45877}"/>
+                <a16:creationId xmlns:a16="http://schemas.microsoft.com/office/drawing/2014/main" id="{5B576ED5-E24B-47D1-B1B6-6B9E9458D3CE}"/>
               </a:ext>
             </a:extLst>
           </p:cNvPr>
@@ -5230,7 +5230,7 @@
           <p:cNvPr id="2" name="">
             <a:extLst xmlns:a="http://schemas.openxmlformats.org/drawingml/2006/main">
               <a:ext uri="{FF2B5EF4-FFF2-40B4-BE49-F238E27FC236}">
-                <a16:creationId xmlns:a16="http://schemas.microsoft.com/office/drawing/2014/main" id="{1B4F9C9B-F0BB-4424-8101-7719EA0CAEF3}"/>
+                <a16:creationId xmlns:a16="http://schemas.microsoft.com/office/drawing/2014/main" id="{7DD0D44C-2661-4509-9500-11F3E39CF08C}"/>
               </a:ext>
             </a:extLst>
           </p:cNvPr>
@@ -5280,7 +5280,7 @@
           <p:cNvPr id="3" name="">
             <a:extLst xmlns:a="http://schemas.openxmlformats.org/drawingml/2006/main">
               <a:ext uri="{FF2B5EF4-FFF2-40B4-BE49-F238E27FC236}">
-                <a16:creationId xmlns:a16="http://schemas.microsoft.com/office/drawing/2014/main" id="{73A068DA-8CE9-4F23-98DF-9D88B8EFA7FE}"/>
+                <a16:creationId xmlns:a16="http://schemas.microsoft.com/office/drawing/2014/main" id="{989EFC72-E634-4A35-B4E0-FF7EE77C5824}"/>
               </a:ext>
             </a:extLst>
           </p:cNvPr>
@@ -5330,7 +5330,7 @@
           <p:cNvPr id="4" name="">
             <a:extLst xmlns:a="http://schemas.openxmlformats.org/drawingml/2006/main">
               <a:ext uri="{FF2B5EF4-FFF2-40B4-BE49-F238E27FC236}">
-                <a16:creationId xmlns:a16="http://schemas.microsoft.com/office/drawing/2014/main" id="{431F26E6-3A2B-4767-BD53-11EDFA99FDDF}"/>
+                <a16:creationId xmlns:a16="http://schemas.microsoft.com/office/drawing/2014/main" id="{7E86EC7A-56EE-43B4-B8AF-DE83BB75CB1A}"/>
               </a:ext>
             </a:extLst>
           </p:cNvPr>
@@ -5361,7 +5361,7 @@
           <p:cNvPr id="5" name="">
             <a:extLst xmlns:a="http://schemas.openxmlformats.org/drawingml/2006/main">
               <a:ext uri="{FF2B5EF4-FFF2-40B4-BE49-F238E27FC236}">
-                <a16:creationId xmlns:a16="http://schemas.microsoft.com/office/drawing/2014/main" id="{6F4B59B3-B0F7-4AFD-923B-F70C6F4FB665}"/>
+                <a16:creationId xmlns:a16="http://schemas.microsoft.com/office/drawing/2014/main" id="{FCF2AA9E-87E0-4F15-863B-DD121ED22510}"/>
               </a:ext>
             </a:extLst>
           </p:cNvPr>
@@ -5411,7 +5411,7 @@
           <p:cNvPr id="6" name="">
             <a:extLst xmlns:a="http://schemas.openxmlformats.org/drawingml/2006/main">
               <a:ext uri="{FF2B5EF4-FFF2-40B4-BE49-F238E27FC236}">
-                <a16:creationId xmlns:a16="http://schemas.microsoft.com/office/drawing/2014/main" id="{7F9F80D8-54C4-4BDF-8E95-0B95008D8C0F}"/>
+                <a16:creationId xmlns:a16="http://schemas.microsoft.com/office/drawing/2014/main" id="{C94CC97E-6EE7-4581-92B4-8367DFB59C7C}"/>
               </a:ext>
             </a:extLst>
           </p:cNvPr>
@@ -5461,7 +5461,7 @@
           <p:cNvPr id="7" name="">
             <a:extLst xmlns:a="http://schemas.openxmlformats.org/drawingml/2006/main">
               <a:ext uri="{FF2B5EF4-FFF2-40B4-BE49-F238E27FC236}">
-                <a16:creationId xmlns:a16="http://schemas.microsoft.com/office/drawing/2014/main" id="{C7745DED-C7A0-40FB-BA06-B1A2FC3A1A2F}"/>
+                <a16:creationId xmlns:a16="http://schemas.microsoft.com/office/drawing/2014/main" id="{DE2ECE4A-197E-46E3-9C42-8EDF4C64ED33}"/>
               </a:ext>
             </a:extLst>
           </p:cNvPr>
@@ -5492,7 +5492,7 @@
           <p:cNvPr id="8" name="">
             <a:extLst xmlns:a="http://schemas.openxmlformats.org/drawingml/2006/main">
               <a:ext uri="{FF2B5EF4-FFF2-40B4-BE49-F238E27FC236}">
-                <a16:creationId xmlns:a16="http://schemas.microsoft.com/office/drawing/2014/main" id="{25C22A4E-5625-4940-B8C4-769324003558}"/>
+                <a16:creationId xmlns:a16="http://schemas.microsoft.com/office/drawing/2014/main" id="{9829074D-E732-4887-A64F-9DD4FF6158A9}"/>
               </a:ext>
             </a:extLst>
           </p:cNvPr>
@@ -5542,7 +5542,7 @@
           <p:cNvPr id="9" name="">
             <a:extLst xmlns:a="http://schemas.openxmlformats.org/drawingml/2006/main">
               <a:ext uri="{FF2B5EF4-FFF2-40B4-BE49-F238E27FC236}">
-                <a16:creationId xmlns:a16="http://schemas.microsoft.com/office/drawing/2014/main" id="{C4936BEC-1A33-424A-9F36-4C6AA534B34F}"/>
+                <a16:creationId xmlns:a16="http://schemas.microsoft.com/office/drawing/2014/main" id="{23F76105-8617-4100-8E5D-9A7BF45DDCAC}"/>
               </a:ext>
             </a:extLst>
           </p:cNvPr>
@@ -5573,7 +5573,7 @@
           <p:cNvPr id="10" name="">
             <a:extLst xmlns:a="http://schemas.openxmlformats.org/drawingml/2006/main">
               <a:ext uri="{FF2B5EF4-FFF2-40B4-BE49-F238E27FC236}">
-                <a16:creationId xmlns:a16="http://schemas.microsoft.com/office/drawing/2014/main" id="{3165EF5E-323C-4F12-90BF-B8CBD7226EA5}"/>
+                <a16:creationId xmlns:a16="http://schemas.microsoft.com/office/drawing/2014/main" id="{5FEF3BEA-2E51-4C87-BFD8-0D652B8D6303}"/>
               </a:ext>
             </a:extLst>
           </p:cNvPr>
@@ -5623,7 +5623,7 @@
           <p:cNvPr id="11" name="">
             <a:extLst xmlns:a="http://schemas.openxmlformats.org/drawingml/2006/main">
               <a:ext uri="{FF2B5EF4-FFF2-40B4-BE49-F238E27FC236}">
-                <a16:creationId xmlns:a16="http://schemas.microsoft.com/office/drawing/2014/main" id="{D56BE9C0-F91D-4614-8202-150B55CAD237}"/>
+                <a16:creationId xmlns:a16="http://schemas.microsoft.com/office/drawing/2014/main" id="{DFDCD792-317C-4794-BA62-EC5876C1C3B9}"/>
               </a:ext>
             </a:extLst>
           </p:cNvPr>
@@ -5654,7 +5654,7 @@
           <p:cNvPr id="12" name="">
             <a:extLst xmlns:a="http://schemas.openxmlformats.org/drawingml/2006/main">
               <a:ext uri="{FF2B5EF4-FFF2-40B4-BE49-F238E27FC236}">
-                <a16:creationId xmlns:a16="http://schemas.microsoft.com/office/drawing/2014/main" id="{1E232425-A5E6-49F8-8146-5612D065C5DE}"/>
+                <a16:creationId xmlns:a16="http://schemas.microsoft.com/office/drawing/2014/main" id="{10CA09A6-1A35-4B4A-9FFB-FFF168838B4F}"/>
               </a:ext>
             </a:extLst>
           </p:cNvPr>
@@ -5704,7 +5704,7 @@
           <p:cNvPr id="13" name="">
             <a:extLst xmlns:a="http://schemas.openxmlformats.org/drawingml/2006/main">
               <a:ext uri="{FF2B5EF4-FFF2-40B4-BE49-F238E27FC236}">
-                <a16:creationId xmlns:a16="http://schemas.microsoft.com/office/drawing/2014/main" id="{81054BA6-C2A2-4F31-A407-5696B69F0D1F}"/>
+                <a16:creationId xmlns:a16="http://schemas.microsoft.com/office/drawing/2014/main" id="{9A4F2CB5-E9D1-4339-B572-32634FEF5CE5}"/>
               </a:ext>
             </a:extLst>
           </p:cNvPr>
@@ -5735,7 +5735,7 @@
           <p:cNvPr id="14" name="">
             <a:extLst xmlns:a="http://schemas.openxmlformats.org/drawingml/2006/main">
               <a:ext uri="{FF2B5EF4-FFF2-40B4-BE49-F238E27FC236}">
-                <a16:creationId xmlns:a16="http://schemas.microsoft.com/office/drawing/2014/main" id="{A3ED160F-75AF-4888-958C-7F4FCBD1BA97}"/>
+                <a16:creationId xmlns:a16="http://schemas.microsoft.com/office/drawing/2014/main" id="{83905278-9324-48F8-B269-FBF6544DA0B6}"/>
               </a:ext>
             </a:extLst>
           </p:cNvPr>
@@ -5785,7 +5785,7 @@
           <p:cNvPr id="15" name="">
             <a:extLst xmlns:a="http://schemas.openxmlformats.org/drawingml/2006/main">
               <a:ext uri="{FF2B5EF4-FFF2-40B4-BE49-F238E27FC236}">
-                <a16:creationId xmlns:a16="http://schemas.microsoft.com/office/drawing/2014/main" id="{3B9AFC6A-A99D-4723-B0BF-30C847A4C696}"/>
+                <a16:creationId xmlns:a16="http://schemas.microsoft.com/office/drawing/2014/main" id="{616C68EF-E6B1-4D6C-9C64-FF6DDCAA0422}"/>
               </a:ext>
             </a:extLst>
           </p:cNvPr>
@@ -5814,7 +5814,7 @@
     </p:spTree>
     <p:extLst>
       <p:ext uri="{BB962C8B-B14F-4D97-AF65-F5344CB8AC3E}">
-        <p14:creationId xmlns:p14="http://schemas.microsoft.com/office/powerpoint/2010/main" val="455895699"/>
+        <p14:creationId xmlns:p14="http://schemas.microsoft.com/office/powerpoint/2010/main" val="2058321437"/>
       </p:ext>
     </p:extLst>
   </p:cSld>
@@ -5845,7 +5845,7 @@
           <p:cNvPr id="9" name="">
             <a:extLst xmlns:a="http://schemas.openxmlformats.org/drawingml/2006/main">
               <a:ext uri="{FF2B5EF4-FFF2-40B4-BE49-F238E27FC236}">
-                <a16:creationId xmlns:a16="http://schemas.microsoft.com/office/drawing/2014/main" id="{51E1E2D0-CD09-4726-8DE8-911AF33F65D1}"/>
+                <a16:creationId xmlns:a16="http://schemas.microsoft.com/office/drawing/2014/main" id="{89E76977-2A2A-4C6D-98EC-E81EF3CF539C}"/>
               </a:ext>
             </a:extLst>
           </p:cNvPr>
@@ -5895,7 +5895,7 @@
           <p:cNvPr id="2" name="">
             <a:extLst xmlns:a="http://schemas.openxmlformats.org/drawingml/2006/main">
               <a:ext uri="{FF2B5EF4-FFF2-40B4-BE49-F238E27FC236}">
-                <a16:creationId xmlns:a16="http://schemas.microsoft.com/office/drawing/2014/main" id="{19A75D31-C3CA-465C-AEEE-319510F0D985}"/>
+                <a16:creationId xmlns:a16="http://schemas.microsoft.com/office/drawing/2014/main" id="{A0079D6D-62F6-4F97-A4BD-B75EEB31101A}"/>
               </a:ext>
             </a:extLst>
           </p:cNvPr>
@@ -5945,7 +5945,7 @@
           <p:cNvPr id="3" name="">
             <a:extLst xmlns:a="http://schemas.openxmlformats.org/drawingml/2006/main">
               <a:ext uri="{FF2B5EF4-FFF2-40B4-BE49-F238E27FC236}">
-                <a16:creationId xmlns:a16="http://schemas.microsoft.com/office/drawing/2014/main" id="{61CD3810-83D5-45E9-9A7E-02C045BFF8BB}"/>
+                <a16:creationId xmlns:a16="http://schemas.microsoft.com/office/drawing/2014/main" id="{666B3A66-D988-49EC-8F77-0182592CEF38}"/>
               </a:ext>
             </a:extLst>
           </p:cNvPr>
@@ -5995,7 +5995,7 @@
           <p:cNvPr id="4" name="">
             <a:extLst xmlns:a="http://schemas.openxmlformats.org/drawingml/2006/main">
               <a:ext uri="{FF2B5EF4-FFF2-40B4-BE49-F238E27FC236}">
-                <a16:creationId xmlns:a16="http://schemas.microsoft.com/office/drawing/2014/main" id="{D78FF725-184B-45AE-A3B4-8F44D7542F12}"/>
+                <a16:creationId xmlns:a16="http://schemas.microsoft.com/office/drawing/2014/main" id="{7CFCC844-CE18-49E5-ABC2-4336A0465242}"/>
               </a:ext>
             </a:extLst>
           </p:cNvPr>
@@ -6026,7 +6026,7 @@
           <p:cNvPr id="5" name="">
             <a:extLst xmlns:a="http://schemas.openxmlformats.org/drawingml/2006/main">
               <a:ext uri="{FF2B5EF4-FFF2-40B4-BE49-F238E27FC236}">
-                <a16:creationId xmlns:a16="http://schemas.microsoft.com/office/drawing/2014/main" id="{21B5B677-0DE0-48A3-9E5E-A2D1D31B1401}"/>
+                <a16:creationId xmlns:a16="http://schemas.microsoft.com/office/drawing/2014/main" id="{D63D017A-5714-4B36-97BB-1C899D01FD6E}"/>
               </a:ext>
             </a:extLst>
           </p:cNvPr>
@@ -6076,7 +6076,7 @@
           <p:cNvPr id="6" name="">
             <a:extLst xmlns:a="http://schemas.openxmlformats.org/drawingml/2006/main">
               <a:ext uri="{FF2B5EF4-FFF2-40B4-BE49-F238E27FC236}">
-                <a16:creationId xmlns:a16="http://schemas.microsoft.com/office/drawing/2014/main" id="{B2150481-504B-4A1A-9D44-140FD8D1F643}"/>
+                <a16:creationId xmlns:a16="http://schemas.microsoft.com/office/drawing/2014/main" id="{D3D5D03E-D741-454B-9B7E-1E636C9BE780}"/>
               </a:ext>
             </a:extLst>
           </p:cNvPr>
@@ -6126,7 +6126,7 @@
           <p:cNvPr id="7" name="">
             <a:extLst xmlns:a="http://schemas.openxmlformats.org/drawingml/2006/main">
               <a:ext uri="{FF2B5EF4-FFF2-40B4-BE49-F238E27FC236}">
-                <a16:creationId xmlns:a16="http://schemas.microsoft.com/office/drawing/2014/main" id="{F22D4E4F-9B02-4C54-AD0C-76EC77C0007E}"/>
+                <a16:creationId xmlns:a16="http://schemas.microsoft.com/office/drawing/2014/main" id="{D0F703E9-2515-4693-BB22-DE415114C34E}"/>
               </a:ext>
             </a:extLst>
           </p:cNvPr>
@@ -6161,7 +6161,7 @@
           <p:cNvPr id="8" name="">
             <a:extLst xmlns:a="http://schemas.openxmlformats.org/drawingml/2006/main">
               <a:ext uri="{FF2B5EF4-FFF2-40B4-BE49-F238E27FC236}">
-                <a16:creationId xmlns:a16="http://schemas.microsoft.com/office/drawing/2014/main" id="{FA8EA220-88B4-4223-A096-8032610A1249}"/>
+                <a16:creationId xmlns:a16="http://schemas.microsoft.com/office/drawing/2014/main" id="{A7187439-BBB5-45DC-B59D-2A8AE9EFB1AC}"/>
               </a:ext>
             </a:extLst>
           </p:cNvPr>
@@ -6209,7 +6209,7 @@
     </p:spTree>
     <p:extLst>
       <p:ext uri="{BB962C8B-B14F-4D97-AF65-F5344CB8AC3E}">
-        <p14:creationId xmlns:p14="http://schemas.microsoft.com/office/powerpoint/2010/main" val="1160964246"/>
+        <p14:creationId xmlns:p14="http://schemas.microsoft.com/office/powerpoint/2010/main" val="2113839237"/>
       </p:ext>
     </p:extLst>
   </p:cSld>

</xml_diff>